<commit_message>
Add reusable site/pptx generator scripts for neurosurgery chapters
</commit_message>
<xml_diff>
--- a/docs/neurosurgery/summaries/01-historical-overview-of-neurosurgery.pptx
+++ b/docs/neurosurgery/summaries/01-historical-overview-of-neurosurgery.pptx
@@ -2396,26 +2396,6 @@
         </p:nvSpPr>
         <p:spPr>
           <a:xfrm>
-            <a:off x="0" y="0"/>
-            <a:ext cx="12188952" cy="6858000"/>
-          </a:xfrm>
-          <a:prstGeom prst="rect">
-            <a:avLst/>
-          </a:prstGeom>
-          <a:solidFill>
-            <a:srgbClr val="0C1B2A"/>
-          </a:solidFill>
-          <a:ln/>
-        </p:spPr>
-      </p:sp>
-      <p:sp>
-        <p:nvSpPr>
-          <p:cNvPr id="3" name="Shape 1"/>
-          <p:cNvSpPr/>
-          <p:nvPr/>
-        </p:nvSpPr>
-        <p:spPr>
-          <a:xfrm>
             <a:off x="5559552" y="640080"/>
             <a:ext cx="1078992" cy="1078992"/>
           </a:xfrm>
@@ -2432,7 +2412,7 @@
       </p:sp>
       <p:sp>
         <p:nvSpPr>
-          <p:cNvPr id="4" name="Shape 2"/>
+          <p:cNvPr id="3" name="Shape 1"/>
           <p:cNvSpPr/>
           <p:nvPr/>
         </p:nvSpPr>
@@ -2452,7 +2432,7 @@
       </p:sp>
       <p:sp>
         <p:nvSpPr>
-          <p:cNvPr id="5" name="Text 3"/>
+          <p:cNvPr id="4" name="Text 2"/>
           <p:cNvSpPr/>
           <p:nvPr/>
         </p:nvSpPr>
@@ -2491,7 +2471,7 @@
       </p:sp>
       <p:sp>
         <p:nvSpPr>
-          <p:cNvPr id="6" name="Text 4"/>
+          <p:cNvPr id="5" name="Text 3"/>
           <p:cNvSpPr/>
           <p:nvPr/>
         </p:nvSpPr>
@@ -2530,7 +2510,7 @@
       </p:sp>
       <p:sp>
         <p:nvSpPr>
-          <p:cNvPr id="7" name="Text 5"/>
+          <p:cNvPr id="6" name="Text 4"/>
           <p:cNvSpPr/>
           <p:nvPr/>
         </p:nvSpPr>
@@ -2569,46 +2549,7 @@
       </p:sp>
       <p:sp>
         <p:nvSpPr>
-          <p:cNvPr id="8" name="Text 6"/>
-          <p:cNvSpPr/>
-          <p:nvPr/>
-        </p:nvSpPr>
-        <p:spPr>
-          <a:xfrm>
-            <a:off x="914400" y="4160520"/>
-            <a:ext cx="10360152" cy="365760"/>
-          </a:xfrm>
-          <a:prstGeom prst="rect">
-            <a:avLst/>
-          </a:prstGeom>
-          <a:noFill/>
-          <a:ln/>
-        </p:spPr>
-        <p:txBody>
-          <a:bodyPr wrap="square" rtlCol="0" anchor="ctr"/>
-          <a:lstStyle/>
-          <a:p>
-            <a:pPr algn="ctr" indent="0" marL="0">
-              <a:buNone/>
-            </a:pPr>
-            <a:r>
-              <a:rPr lang="en-US" sz="1300" dirty="0">
-                <a:solidFill>
-                  <a:srgbClr val="9CA3AF"/>
-                </a:solidFill>
-                <a:latin typeface="Calibri" pitchFamily="34" charset="0"/>
-                <a:ea typeface="Calibri" pitchFamily="34" charset="-122"/>
-                <a:cs typeface="Calibri" pitchFamily="34" charset="-120"/>
-              </a:rPr>
-              <a:t>James Tait Goodrich &amp; Eugene S. Flamm</a:t>
-            </a:r>
-            <a:endParaRPr lang="en-US" sz="1300" dirty="0"/>
-          </a:p>
-        </p:txBody>
-      </p:sp>
-      <p:sp>
-        <p:nvSpPr>
-          <p:cNvPr id="9" name="Text 7"/>
+          <p:cNvPr id="7" name="Text 5"/>
           <p:cNvSpPr/>
           <p:nvPr/>
         </p:nvSpPr>
@@ -4241,7 +4182,7 @@
             </a:avLst>
           </a:prstGeom>
           <a:solidFill>
-            <a:srgbClr val="1C7293"/>
+            <a:srgbClr val="990011"/>
           </a:solidFill>
           <a:ln/>
         </p:spPr>
@@ -4912,7 +4853,7 @@
             </a:avLst>
           </a:prstGeom>
           <a:solidFill>
-            <a:srgbClr val="1C7293"/>
+            <a:srgbClr val="990011"/>
           </a:solidFill>
           <a:ln/>
         </p:spPr>
@@ -5788,7 +5729,7 @@
             </a:avLst>
           </a:prstGeom>
           <a:solidFill>
-            <a:srgbClr val="1C7293"/>
+            <a:srgbClr val="990011"/>
           </a:solidFill>
           <a:ln/>
         </p:spPr>
@@ -6459,7 +6400,7 @@
             </a:avLst>
           </a:prstGeom>
           <a:solidFill>
-            <a:srgbClr val="1C7293"/>
+            <a:srgbClr val="990011"/>
           </a:solidFill>
           <a:ln/>
         </p:spPr>
@@ -7335,7 +7276,7 @@
             </a:avLst>
           </a:prstGeom>
           <a:solidFill>
-            <a:srgbClr val="1C7293"/>
+            <a:srgbClr val="990011"/>
           </a:solidFill>
           <a:ln/>
         </p:spPr>
@@ -8006,7 +7947,7 @@
             </a:avLst>
           </a:prstGeom>
           <a:solidFill>
-            <a:srgbClr val="1C7293"/>
+            <a:srgbClr val="990011"/>
           </a:solidFill>
           <a:ln/>
         </p:spPr>
@@ -8898,7 +8839,7 @@
                 <a:ea typeface="Calibri" pitchFamily="34" charset="-122"/>
                 <a:cs typeface="Calibri" pitchFamily="34" charset="-120"/>
               </a:rPr>
-              <a:t>סיכום של הסיכום</a:t>
+              <a:t>סיכום הכרטיסיות</a:t>
             </a:r>
             <a:endParaRPr lang="en-US" sz="3000" dirty="0"/>
           </a:p>
@@ -8927,7 +8868,7 @@
           <a:p>
             <a:pPr rtl="1" algn="r" marL="342900" indent="-342900">
               <a:spcAft>
-                <a:spcPts val="1400"/>
+                <a:spcPts val="1200"/>
               </a:spcAft>
               <a:buSzPct val="100000"/>
               <a:buChar char="●"/>
@@ -8941,14 +8882,14 @@
                 <a:ea typeface="Calibri" pitchFamily="34" charset="-122"/>
                 <a:cs typeface="Calibri" pitchFamily="34" charset="-120"/>
               </a:rPr>
-              <a:t>נוירוכירורגיה התקדמה בכל פעם שהובנה טוב יותר האנטומיה או הפיזיולוגיה של מערכת העצבים.</a:t>
+              <a:t>Edwin Smith Papyrus</a:t>
             </a:r>
             <a:endParaRPr lang="en-US" sz="1600" dirty="0"/>
           </a:p>
           <a:p>
             <a:pPr rtl="1" algn="r" marL="342900" indent="-342900">
               <a:spcAft>
-                <a:spcPts val="1400"/>
+                <a:spcPts val="1200"/>
               </a:spcAft>
               <a:buSzPct val="100000"/>
               <a:buChar char="●"/>
@@ -8962,14 +8903,14 @@
                 <a:ea typeface="Calibri" pitchFamily="34" charset="-122"/>
                 <a:cs typeface="Calibri" pitchFamily="34" charset="-120"/>
               </a:rPr>
-              <a:t>ארבע פריצות דרך (A-A-L-I): אנטומיה (וסליוס 1543) ← הרדמה+אנטיספסיס (המאה 19) ← לוקליזציה (מאקיואן) ← דימות (דנדי, מוניז).</a:t>
+              <a:t>פרוגנוזה</a:t>
             </a:r>
             <a:endParaRPr lang="en-US" sz="1600" dirty="0"/>
           </a:p>
           <a:p>
             <a:pPr rtl="1" algn="r" marL="342900" indent="-342900">
               <a:spcAft>
-                <a:spcPts val="1400"/>
+                <a:spcPts val="1200"/>
               </a:spcAft>
               <a:buSzPct val="100000"/>
               <a:buChar char="●"/>
@@ -8983,14 +8924,14 @@
                 <a:ea typeface="Calibri" pitchFamily="34" charset="-122"/>
                 <a:cs typeface="Calibri" pitchFamily="34" charset="-120"/>
               </a:rPr>
-              <a:t>Edwin Smith Papyrus: ספר הלימוד הכירורגי המתועד הראשון, כולל אבחנה ופרוגנוזה.</a:t>
+              <a:t>טרפנציה</a:t>
             </a:r>
             <a:endParaRPr lang="en-US" sz="1600" dirty="0"/>
           </a:p>
           <a:p>
             <a:pPr rtl="1" algn="r" marL="342900" indent="-342900">
               <a:spcAft>
-                <a:spcPts val="1400"/>
+                <a:spcPts val="1200"/>
               </a:spcAft>
               <a:buSzPct val="100000"/>
               <a:buChar char="●"/>
@@ -9004,14 +8945,14 @@
                 <a:ea typeface="Calibri" pitchFamily="34" charset="-122"/>
                 <a:cs typeface="Calibri" pitchFamily="34" charset="-120"/>
               </a:rPr>
-              <a:t>גאלנוס ביסס אנטומיה על נתיחת בעלי חיים; סמכותו נותרה כמעט בלתי-מעורערת כ-1400 שנה, עד וסליוס.</a:t>
+              <a:t>De Capitis Vulneribus</a:t>
             </a:r>
             <a:endParaRPr lang="en-US" sz="1600" dirty="0"/>
           </a:p>
           <a:p>
             <a:pPr rtl="1" algn="r" marL="342900" indent="-342900">
               <a:spcAft>
-                <a:spcPts val="1400"/>
+                <a:spcPts val="1200"/>
               </a:spcAft>
               <a:buSzPct val="100000"/>
               <a:buChar char="●"/>
@@ -9025,7 +8966,154 @@
                 <a:ea typeface="Calibri" pitchFamily="34" charset="-122"/>
                 <a:cs typeface="Calibri" pitchFamily="34" charset="-120"/>
               </a:rPr>
-              <a:t>קושינג ('אבי הנוירוכירורגיה האמריקאית') ודנדי הפכו את התחום לתת-התמחות מודרנית בראשית המאה ה-20.</a:t>
+              <a:t>שבר גולגולת</a:t>
+            </a:r>
+            <a:endParaRPr lang="en-US" sz="1600" dirty="0"/>
+          </a:p>
+          <a:p>
+            <a:pPr rtl="1" algn="r" marL="342900" indent="-342900">
+              <a:spcAft>
+                <a:spcPts val="1200"/>
+              </a:spcAft>
+              <a:buSzPct val="100000"/>
+              <a:buChar char="●"/>
+            </a:pPr>
+            <a:r>
+              <a:rPr lang="en-US" sz="1600" dirty="0">
+                <a:solidFill>
+                  <a:srgbClr val="E5E7EB"/>
+                </a:solidFill>
+                <a:latin typeface="Calibri" pitchFamily="34" charset="0"/>
+                <a:ea typeface="Calibri" pitchFamily="34" charset="-122"/>
+                <a:cs typeface="Calibri" pitchFamily="34" charset="-120"/>
+              </a:rPr>
+              <a:t>גאלנוס</a:t>
+            </a:r>
+            <a:endParaRPr lang="en-US" sz="1600" dirty="0"/>
+          </a:p>
+          <a:p>
+            <a:pPr rtl="1" algn="r" marL="342900" indent="-342900">
+              <a:spcAft>
+                <a:spcPts val="1200"/>
+              </a:spcAft>
+              <a:buSzPct val="100000"/>
+              <a:buChar char="●"/>
+            </a:pPr>
+            <a:r>
+              <a:rPr lang="en-US" sz="1600" dirty="0">
+                <a:solidFill>
+                  <a:srgbClr val="E5E7EB"/>
+                </a:solidFill>
+                <a:latin typeface="Calibri" pitchFamily="34" charset="0"/>
+                <a:ea typeface="Calibri" pitchFamily="34" charset="-122"/>
+                <a:cs typeface="Calibri" pitchFamily="34" charset="-120"/>
+              </a:rPr>
+              <a:t>וסליוס</a:t>
+            </a:r>
+            <a:endParaRPr lang="en-US" sz="1600" dirty="0"/>
+          </a:p>
+          <a:p>
+            <a:pPr rtl="1" algn="r" marL="342900" indent="-342900">
+              <a:spcAft>
+                <a:spcPts val="1200"/>
+              </a:spcAft>
+              <a:buSzPct val="100000"/>
+              <a:buChar char="●"/>
+            </a:pPr>
+            <a:r>
+              <a:rPr lang="en-US" sz="1600" dirty="0">
+                <a:solidFill>
+                  <a:srgbClr val="E5E7EB"/>
+                </a:solidFill>
+                <a:latin typeface="Calibri" pitchFamily="34" charset="0"/>
+                <a:ea typeface="Calibri" pitchFamily="34" charset="-122"/>
+                <a:cs typeface="Calibri" pitchFamily="34" charset="-120"/>
+              </a:rPr>
+              <a:t>Opera Omnia</a:t>
+            </a:r>
+            <a:endParaRPr lang="en-US" sz="1600" dirty="0"/>
+          </a:p>
+          <a:p>
+            <a:pPr rtl="1" algn="r" marL="342900" indent="-342900">
+              <a:spcAft>
+                <a:spcPts val="1200"/>
+              </a:spcAft>
+              <a:buSzPct val="100000"/>
+              <a:buChar char="●"/>
+            </a:pPr>
+            <a:r>
+              <a:rPr lang="en-US" sz="1600" dirty="0">
+                <a:solidFill>
+                  <a:srgbClr val="E5E7EB"/>
+                </a:solidFill>
+                <a:latin typeface="Calibri" pitchFamily="34" charset="0"/>
+                <a:ea typeface="Calibri" pitchFamily="34" charset="-122"/>
+                <a:cs typeface="Calibri" pitchFamily="34" charset="-120"/>
+              </a:rPr>
+              <a:t>נתיחת אדם</a:t>
+            </a:r>
+            <a:endParaRPr lang="en-US" sz="1600" dirty="0"/>
+          </a:p>
+          <a:p>
+            <a:pPr rtl="1" algn="r" marL="342900" indent="-342900">
+              <a:spcAft>
+                <a:spcPts val="1200"/>
+              </a:spcAft>
+              <a:buSzPct val="100000"/>
+              <a:buChar char="●"/>
+            </a:pPr>
+            <a:r>
+              <a:rPr lang="en-US" sz="1600" dirty="0">
+                <a:solidFill>
+                  <a:srgbClr val="E5E7EB"/>
+                </a:solidFill>
+                <a:latin typeface="Calibri" pitchFamily="34" charset="0"/>
+                <a:ea typeface="Calibri" pitchFamily="34" charset="-122"/>
+                <a:cs typeface="Calibri" pitchFamily="34" charset="-120"/>
+              </a:rPr>
+              <a:t>Canon Medicinae</a:t>
+            </a:r>
+            <a:endParaRPr lang="en-US" sz="1600" dirty="0"/>
+          </a:p>
+          <a:p>
+            <a:pPr rtl="1" algn="r" marL="342900" indent="-342900">
+              <a:spcAft>
+                <a:spcPts val="1200"/>
+              </a:spcAft>
+              <a:buSzPct val="100000"/>
+              <a:buChar char="●"/>
+            </a:pPr>
+            <a:r>
+              <a:rPr lang="en-US" sz="1600" dirty="0">
+                <a:solidFill>
+                  <a:srgbClr val="E5E7EB"/>
+                </a:solidFill>
+                <a:latin typeface="Calibri" pitchFamily="34" charset="0"/>
+                <a:ea typeface="Calibri" pitchFamily="34" charset="-122"/>
+                <a:cs typeface="Calibri" pitchFamily="34" charset="-120"/>
+              </a:rPr>
+              <a:t>אבן סינא</a:t>
+            </a:r>
+            <a:endParaRPr lang="en-US" sz="1600" dirty="0"/>
+          </a:p>
+          <a:p>
+            <a:pPr rtl="1" algn="r" marL="342900" indent="-342900">
+              <a:spcAft>
+                <a:spcPts val="1200"/>
+              </a:spcAft>
+              <a:buSzPct val="100000"/>
+              <a:buChar char="●"/>
+            </a:pPr>
+            <a:r>
+              <a:rPr lang="en-US" sz="1600" dirty="0">
+                <a:solidFill>
+                  <a:srgbClr val="E5E7EB"/>
+                </a:solidFill>
+                <a:latin typeface="Calibri" pitchFamily="34" charset="0"/>
+                <a:ea typeface="Calibri" pitchFamily="34" charset="-122"/>
+                <a:cs typeface="Calibri" pitchFamily="34" charset="-120"/>
+              </a:rPr>
+              <a:t>caudate nucleus</a:t>
             </a:r>
             <a:endParaRPr lang="en-US" sz="1600" dirty="0"/>
           </a:p>
@@ -9119,7 +9207,7 @@
             </a:avLst>
           </a:prstGeom>
           <a:solidFill>
-            <a:srgbClr val="B85042"/>
+            <a:srgbClr val="1C7293"/>
           </a:solidFill>
           <a:ln/>
         </p:spPr>
@@ -9790,7 +9878,7 @@
             </a:avLst>
           </a:prstGeom>
           <a:solidFill>
-            <a:srgbClr val="B85042"/>
+            <a:srgbClr val="1C7293"/>
           </a:solidFill>
           <a:ln/>
         </p:spPr>
@@ -10666,7 +10754,7 @@
             </a:avLst>
           </a:prstGeom>
           <a:solidFill>
-            <a:srgbClr val="21295C"/>
+            <a:srgbClr val="B85042"/>
           </a:solidFill>
           <a:ln/>
         </p:spPr>
@@ -11337,7 +11425,7 @@
             </a:avLst>
           </a:prstGeom>
           <a:solidFill>
-            <a:srgbClr val="21295C"/>
+            <a:srgbClr val="B85042"/>
           </a:solidFill>
           <a:ln/>
         </p:spPr>
@@ -12213,7 +12301,7 @@
             </a:avLst>
           </a:prstGeom>
           <a:solidFill>
-            <a:srgbClr val="1C7293"/>
+            <a:srgbClr val="21295C"/>
           </a:solidFill>
           <a:ln/>
         </p:spPr>
@@ -12884,7 +12972,7 @@
             </a:avLst>
           </a:prstGeom>
           <a:solidFill>
-            <a:srgbClr val="1C7293"/>
+            <a:srgbClr val="21295C"/>
           </a:solidFill>
           <a:ln/>
         </p:spPr>

</xml_diff>